<commit_message>
Resultados con chunking: clasificacion real 0.176 -> 0.293, NER real sobre 585 entidades
</commit_message>
<xml_diff>
--- a/entregables/TP_Final_Deep_Learning_Vassarotto.pptx
+++ b/entregables/TP_Final_Deep_Learning_Vassarotto.pptx
@@ -5518,7 +5518,7 @@
                 </a:solidFill>
                 <a:latin typeface="Arial"/>
               </a:rPr>
-              <a:t>99.7%</a:t>
+              <a:t>99.5%</a:t>
             </a:r>
           </a:p>
           <a:p>
@@ -5584,7 +5584,7 @@
                 </a:solidFill>
                 <a:latin typeface="Arial"/>
               </a:rPr>
-              <a:t>22.2%</a:t>
+              <a:t>19.7%</a:t>
             </a:r>
           </a:p>
           <a:p>
@@ -5650,7 +5650,7 @@
                 </a:solidFill>
                 <a:latin typeface="Arial"/>
               </a:rPr>
-              <a:t>97.1%</a:t>
+              <a:t>100.0%</a:t>
             </a:r>
           </a:p>
           <a:p>
@@ -5716,7 +5716,7 @@
                 </a:solidFill>
                 <a:latin typeface="Arial"/>
               </a:rPr>
-              <a:t>17.6%</a:t>
+              <a:t>29.3%</a:t>
             </a:r>
           </a:p>
           <a:p>

</xml_diff>

<commit_message>
Medir si la ficha tabulada del portal hace redundante el NLP: son complementarias (18 amenities solo en el texto, 13 solo en la ficha)
</commit_message>
<xml_diff>
--- a/entregables/TP_Final_Deep_Learning_Vassarotto.pptx
+++ b/entregables/TP_Final_Deep_Learning_Vassarotto.pptx
@@ -17,6 +17,7 @@
     <p:sldId id="265" r:id="rId16"/>
     <p:sldId id="266" r:id="rId17"/>
     <p:sldId id="267" r:id="rId18"/>
+    <p:sldId id="268" r:id="rId19"/>
   </p:sldIdLst>
   <p:sldSz cx="12191695" cy="6858000" type="screen4x3"/>
   <p:notesSz cx="6858000" cy="9144000"/>
@@ -3329,7 +3330,7 @@
                 </a:solidFill>
                 <a:latin typeface="Arial"/>
               </a:rPr>
-              <a:t>Limitaciones</a:t>
+              <a:t>«¿Y si el portal ya publica los atributos?»</a:t>
             </a:r>
           </a:p>
         </p:txBody>
@@ -3387,7 +3388,7 @@
         <p:spPr>
           <a:xfrm>
             <a:off x="822960" y="1600200"/>
-            <a:ext cx="10515600" cy="4206240"/>
+            <a:ext cx="10515600" cy="548640"/>
           </a:xfrm>
           <a:prstGeom prst="rect">
             <a:avLst/>
@@ -3402,6 +3403,45 @@
           <a:p>
             <a:pPr algn="l">
               <a:spcAft>
+                <a:spcPts val="800"/>
+              </a:spcAft>
+            </a:pPr>
+            <a:r>
+              <a:rPr sz="1500" b="1">
+                <a:solidFill>
+                  <a:srgbClr val="C9A24B"/>
+                </a:solidFill>
+                <a:latin typeface="Arial"/>
+              </a:rPr>
+              <a:t>La objeción más razonable al trabajo, respondida con datos</a:t>
+            </a:r>
+          </a:p>
+        </p:txBody>
+      </p:sp>
+      <p:sp>
+        <p:nvSpPr>
+          <p:cNvPr id="5" name="TextBox 4"/>
+          <p:cNvSpPr txBox="1"/>
+          <p:nvPr/>
+        </p:nvSpPr>
+        <p:spPr>
+          <a:xfrm>
+            <a:off x="822960" y="2148840"/>
+            <a:ext cx="10515600" cy="4206240"/>
+          </a:xfrm>
+          <a:prstGeom prst="rect">
+            <a:avLst/>
+          </a:prstGeom>
+          <a:noFill/>
+        </p:spPr>
+        <p:txBody>
+          <a:bodyPr wrap="square">
+            <a:spAutoFit/>
+          </a:bodyPr>
+          <a:lstStyle/>
+          <a:p>
+            <a:pPr algn="l">
+              <a:spcAft>
                 <a:spcPts val="1100"/>
               </a:spcAft>
             </a:pPr>
@@ -3412,7 +3452,7 @@
                 </a:solidFill>
                 <a:latin typeface="Arial"/>
               </a:rPr>
-              <a:t>•  Volumen del scrape. La propuesta apuntaba a 8.000–15.000 avisos; se trabajó con un volumen mucho menor. El anti-bot del portal (DataDome/Cloudflare) y el rate-limiting cortés hacen que una corrida completa lleve muchas horas. El objetivo fue demostrar que la arquitectura funciona.</a:t>
+              <a:t>Argenprop SÍ expone una ficha estructurada en cada página de detalle: 38 items tildados y 20 pares clave-valor. La objeción es válida, así que se midió.</a:t>
             </a:r>
           </a:p>
           <a:p>
@@ -3444,7 +3484,7 @@
                 </a:solidFill>
                 <a:latin typeface="Arial"/>
               </a:rPr>
-              <a:t>•  Entrenamiento sobre datos sintéticos, con el conjunto real como evaluación externa. Un dataset real y grande daría mejores resultados.</a:t>
+              <a:t>Sobre una muestra de 10 avisos, comparando ambas fuentes con el mismo vocabulario:</a:t>
             </a:r>
           </a:p>
           <a:p>
@@ -3460,6 +3500,70 @@
                 </a:solidFill>
                 <a:latin typeface="Arial"/>
               </a:rPr>
+              <a:t>      • Amenities tildados en la ficha:            31</a:t>
+            </a:r>
+          </a:p>
+          <a:p>
+            <a:pPr algn="l">
+              <a:spcAft>
+                <a:spcPts val="1100"/>
+              </a:spcAft>
+            </a:pPr>
+            <a:r>
+              <a:rPr sz="1500" b="0">
+                <a:solidFill>
+                  <a:srgbClr val="444A55"/>
+                </a:solidFill>
+                <a:latin typeface="Arial"/>
+              </a:rPr>
+              <a:t>      • Amenities mencionados en la descripción:   36</a:t>
+            </a:r>
+          </a:p>
+          <a:p>
+            <a:pPr algn="l">
+              <a:spcAft>
+                <a:spcPts val="1100"/>
+              </a:spcAft>
+            </a:pPr>
+            <a:r>
+              <a:rPr sz="1500" b="0">
+                <a:solidFill>
+                  <a:srgbClr val="444A55"/>
+                </a:solidFill>
+                <a:latin typeface="Arial"/>
+              </a:rPr>
+              <a:t>      • SÓLO en la descripción (se perderían):     18</a:t>
+            </a:r>
+          </a:p>
+          <a:p>
+            <a:pPr algn="l">
+              <a:spcAft>
+                <a:spcPts val="1100"/>
+              </a:spcAft>
+            </a:pPr>
+            <a:r>
+              <a:rPr sz="1500" b="0">
+                <a:solidFill>
+                  <a:srgbClr val="444A55"/>
+                </a:solidFill>
+                <a:latin typeface="Arial"/>
+              </a:rPr>
+              <a:t>      • SÓLO en la ficha:                          13</a:t>
+            </a:r>
+          </a:p>
+          <a:p>
+            <a:pPr algn="l">
+              <a:spcAft>
+                <a:spcPts val="1100"/>
+              </a:spcAft>
+            </a:pPr>
+            <a:r>
+              <a:rPr sz="1500" b="0">
+                <a:solidFill>
+                  <a:srgbClr val="444A55"/>
+                </a:solidFill>
+                <a:latin typeface="Arial"/>
+              </a:rPr>
               <a:t/>
             </a:r>
           </a:p>
@@ -3476,7 +3580,7 @@
                 </a:solidFill>
                 <a:latin typeface="Arial"/>
               </a:rPr>
-              <a:t>•  Anotación semiautomática. El pre-anotador es un LLM chico (llama3.2:3b, por la restricción de 4 GB de VRAM); sus errores se propagan a las etiquetas, y por eso la revisión manual del subconjunto.</a:t>
+              <a:t>LAS DOS FUENTES SON COMPLEMENTARIAS, NO REDUNDANTES. Ninguna contiene a la otra: la ficha la completa el publicador, y cada uno completa distinto.</a:t>
             </a:r>
           </a:p>
           <a:p>
@@ -3508,7 +3612,7 @@
                 </a:solidFill>
                 <a:latin typeface="Arial"/>
               </a:rPr>
-              <a:t>•  Términos de uso. Scraping con fines académicos, a ritmo razonable y sin redistribuir el contenido del portal.</a:t>
+              <a:t>Y las señales del vendedor —«escucho ofertas», «venta urgente»— no tienen equivalente tabulado en ningún portal. Ahí el NLP no compite con nada.</a:t>
             </a:r>
           </a:p>
         </p:txBody>
@@ -3573,7 +3677,7 @@
                 </a:solidFill>
                 <a:latin typeface="Arial"/>
               </a:rPr>
-              <a:t>Trabajo futuro</a:t>
+              <a:t>Limitaciones</a:t>
             </a:r>
           </a:p>
         </p:txBody>
@@ -3631,7 +3735,7 @@
         <p:spPr>
           <a:xfrm>
             <a:off x="822960" y="1600200"/>
-            <a:ext cx="10515600" cy="548640"/>
+            <a:ext cx="10515600" cy="4206240"/>
           </a:xfrm>
           <a:prstGeom prst="rect">
             <a:avLst/>
@@ -3646,66 +3750,27 @@
           <a:p>
             <a:pPr algn="l">
               <a:spcAft>
-                <a:spcPts val="800"/>
-              </a:spcAft>
-            </a:pPr>
-            <a:r>
-              <a:rPr sz="1500" b="1">
-                <a:solidFill>
-                  <a:srgbClr val="C9A24B"/>
-                </a:solidFill>
-                <a:latin typeface="Arial"/>
-              </a:rPr>
-              <a:t>La motivación detrás del proyecto</a:t>
-            </a:r>
-          </a:p>
-        </p:txBody>
-      </p:sp>
-      <p:sp>
-        <p:nvSpPr>
-          <p:cNvPr id="5" name="TextBox 4"/>
-          <p:cNvSpPr txBox="1"/>
-          <p:nvPr/>
-        </p:nvSpPr>
-        <p:spPr>
-          <a:xfrm>
-            <a:off x="822960" y="2148840"/>
-            <a:ext cx="10515600" cy="4206240"/>
-          </a:xfrm>
-          <a:prstGeom prst="rect">
-            <a:avLst/>
-          </a:prstGeom>
-          <a:noFill/>
-        </p:spPr>
-        <p:txBody>
-          <a:bodyPr wrap="square">
-            <a:spAutoFit/>
-          </a:bodyPr>
-          <a:lstStyle/>
-          <a:p>
-            <a:pPr algn="l">
-              <a:spcAft>
-                <a:spcPts val="1100"/>
-              </a:spcAft>
-            </a:pPr>
-            <a:r>
-              <a:rPr sz="1700" b="0">
-                <a:solidFill>
-                  <a:srgbClr val="444A55"/>
-                </a:solidFill>
-                <a:latin typeface="Arial"/>
-              </a:rPr>
-              <a:t>Los atributos generados por esta capa de NLP están pensados para integrarse, en el marco de la tesis de la maestría, como features de un modelo hedónico de valuación para detectar activos subvaluados en CABA.</a:t>
-            </a:r>
-          </a:p>
-          <a:p>
-            <a:pPr algn="l">
-              <a:spcAft>
-                <a:spcPts val="1100"/>
-              </a:spcAft>
-            </a:pPr>
-            <a:r>
-              <a:rPr sz="1700" b="0">
+                <a:spcPts val="1100"/>
+              </a:spcAft>
+            </a:pPr>
+            <a:r>
+              <a:rPr sz="1500" b="0">
+                <a:solidFill>
+                  <a:srgbClr val="444A55"/>
+                </a:solidFill>
+                <a:latin typeface="Arial"/>
+              </a:rPr>
+              <a:t>•  Volumen del scrape. La propuesta apuntaba a 8.000–15.000 avisos; se trabajó con un volumen mucho menor. El anti-bot del portal (DataDome/Cloudflare) y el rate-limiting cortés hacen que una corrida completa lleve muchas horas. El objetivo fue demostrar que la arquitectura funciona.</a:t>
+            </a:r>
+          </a:p>
+          <a:p>
+            <a:pPr algn="l">
+              <a:spcAft>
+                <a:spcPts val="1100"/>
+              </a:spcAft>
+            </a:pPr>
+            <a:r>
+              <a:rPr sz="1500" b="0">
                 <a:solidFill>
                   <a:srgbClr val="444A55"/>
                 </a:solidFill>
@@ -3721,23 +3786,23 @@
               </a:spcAft>
             </a:pPr>
             <a:r>
-              <a:rPr sz="1700" b="0">
-                <a:solidFill>
-                  <a:srgbClr val="444A55"/>
-                </a:solidFill>
-                <a:latin typeface="Arial"/>
-              </a:rPr>
-              <a:t>La hipótesis a testear: que las variables latentes extraídas del texto libre aporten poder explicativo por encima de los atributos tabulares tradicionales (metros, ambientes, ubicación, antigüedad).</a:t>
-            </a:r>
-          </a:p>
-          <a:p>
-            <a:pPr algn="l">
-              <a:spcAft>
-                <a:spcPts val="1100"/>
-              </a:spcAft>
-            </a:pPr>
-            <a:r>
-              <a:rPr sz="1700" b="0">
+              <a:rPr sz="1500" b="0">
+                <a:solidFill>
+                  <a:srgbClr val="444A55"/>
+                </a:solidFill>
+                <a:latin typeface="Arial"/>
+              </a:rPr>
+              <a:t>•  Entrenamiento sobre datos sintéticos, con el conjunto real como evaluación externa. Un dataset real y grande daría mejores resultados.</a:t>
+            </a:r>
+          </a:p>
+          <a:p>
+            <a:pPr algn="l">
+              <a:spcAft>
+                <a:spcPts val="1100"/>
+              </a:spcAft>
+            </a:pPr>
+            <a:r>
+              <a:rPr sz="1500" b="0">
                 <a:solidFill>
                   <a:srgbClr val="444A55"/>
                 </a:solidFill>
@@ -3753,13 +3818,45 @@
               </a:spcAft>
             </a:pPr>
             <a:r>
-              <a:rPr sz="1700" b="0">
-                <a:solidFill>
-                  <a:srgbClr val="444A55"/>
-                </a:solidFill>
-                <a:latin typeface="Arial"/>
-              </a:rPr>
-              <a:t>Esa integración excede el alcance del presente Trabajo Final y se menciona para dar cuenta de la continuidad del proyecto.</a:t>
+              <a:rPr sz="1500" b="0">
+                <a:solidFill>
+                  <a:srgbClr val="444A55"/>
+                </a:solidFill>
+                <a:latin typeface="Arial"/>
+              </a:rPr>
+              <a:t>•  Anotación semiautomática. El pre-anotador es un LLM chico (llama3.2:3b, por la restricción de 4 GB de VRAM); sus errores se propagan a las etiquetas, y por eso la revisión manual del subconjunto.</a:t>
+            </a:r>
+          </a:p>
+          <a:p>
+            <a:pPr algn="l">
+              <a:spcAft>
+                <a:spcPts val="1100"/>
+              </a:spcAft>
+            </a:pPr>
+            <a:r>
+              <a:rPr sz="1500" b="0">
+                <a:solidFill>
+                  <a:srgbClr val="444A55"/>
+                </a:solidFill>
+                <a:latin typeface="Arial"/>
+              </a:rPr>
+              <a:t/>
+            </a:r>
+          </a:p>
+          <a:p>
+            <a:pPr algn="l">
+              <a:spcAft>
+                <a:spcPts val="1100"/>
+              </a:spcAft>
+            </a:pPr>
+            <a:r>
+              <a:rPr sz="1500" b="0">
+                <a:solidFill>
+                  <a:srgbClr val="444A55"/>
+                </a:solidFill>
+                <a:latin typeface="Arial"/>
+              </a:rPr>
+              <a:t>•  Términos de uso. Scraping con fines académicos, a ritmo razonable y sin redistribuir el contenido del portal.</a:t>
             </a:r>
           </a:p>
         </p:txBody>
@@ -3773,6 +3870,257 @@
 </file>
 
 <file path=ppt/slides/slide12.xml><?xml version="1.0" encoding="utf-8"?>
+<p:sld xmlns:a="http://schemas.openxmlformats.org/drawingml/2006/main" xmlns:p="http://schemas.openxmlformats.org/presentationml/2006/main" xmlns:r="http://schemas.openxmlformats.org/officeDocument/2006/relationships">
+  <p:cSld>
+    <p:bg>
+      <p:bgPr>
+        <a:solidFill>
+          <a:srgbClr val="FFFFFF"/>
+        </a:solidFill>
+        <a:effectLst/>
+      </p:bgPr>
+    </p:bg>
+    <p:spTree>
+      <p:nvGrpSpPr>
+        <p:cNvPr id="1" name=""/>
+        <p:cNvGrpSpPr/>
+        <p:nvPr/>
+      </p:nvGrpSpPr>
+      <p:grpSpPr/>
+      <p:sp>
+        <p:nvSpPr>
+          <p:cNvPr id="2" name="TextBox 1"/>
+          <p:cNvSpPr txBox="1"/>
+          <p:nvPr/>
+        </p:nvSpPr>
+        <p:spPr>
+          <a:xfrm>
+            <a:off x="822960" y="502920"/>
+            <a:ext cx="10515600" cy="822960"/>
+          </a:xfrm>
+          <a:prstGeom prst="rect">
+            <a:avLst/>
+          </a:prstGeom>
+          <a:noFill/>
+        </p:spPr>
+        <p:txBody>
+          <a:bodyPr wrap="square">
+            <a:spAutoFit/>
+          </a:bodyPr>
+          <a:lstStyle/>
+          <a:p>
+            <a:pPr algn="l">
+              <a:spcAft>
+                <a:spcPts val="800"/>
+              </a:spcAft>
+            </a:pPr>
+            <a:r>
+              <a:rPr sz="2800" b="1">
+                <a:solidFill>
+                  <a:srgbClr val="16243D"/>
+                </a:solidFill>
+                <a:latin typeface="Arial"/>
+              </a:rPr>
+              <a:t>Trabajo futuro</a:t>
+            </a:r>
+          </a:p>
+        </p:txBody>
+      </p:sp>
+      <p:sp>
+        <p:nvSpPr>
+          <p:cNvPr id="3" name="Rectangle 2"/>
+          <p:cNvSpPr/>
+          <p:nvPr/>
+        </p:nvSpPr>
+        <p:spPr>
+          <a:xfrm>
+            <a:off x="822960" y="1234440"/>
+            <a:ext cx="2011680" cy="44450"/>
+          </a:xfrm>
+          <a:prstGeom prst="rect">
+            <a:avLst/>
+          </a:prstGeom>
+          <a:solidFill>
+            <a:srgbClr val="C9A24B"/>
+          </a:solidFill>
+          <a:ln>
+            <a:noFill/>
+          </a:ln>
+          <a:effectLst/>
+        </p:spPr>
+        <p:style>
+          <a:lnRef idx="1">
+            <a:schemeClr val="accent1"/>
+          </a:lnRef>
+          <a:fillRef idx="3">
+            <a:schemeClr val="accent1"/>
+          </a:fillRef>
+          <a:effectRef idx="2">
+            <a:schemeClr val="accent1"/>
+          </a:effectRef>
+          <a:fontRef idx="minor">
+            <a:schemeClr val="lt1"/>
+          </a:fontRef>
+        </p:style>
+        <p:txBody>
+          <a:bodyPr rtlCol="0" anchor="ctr"/>
+          <a:lstStyle/>
+          <a:p>
+            <a:pPr algn="ctr"/>
+          </a:p>
+        </p:txBody>
+      </p:sp>
+      <p:sp>
+        <p:nvSpPr>
+          <p:cNvPr id="4" name="TextBox 3"/>
+          <p:cNvSpPr txBox="1"/>
+          <p:nvPr/>
+        </p:nvSpPr>
+        <p:spPr>
+          <a:xfrm>
+            <a:off x="822960" y="1600200"/>
+            <a:ext cx="10515600" cy="548640"/>
+          </a:xfrm>
+          <a:prstGeom prst="rect">
+            <a:avLst/>
+          </a:prstGeom>
+          <a:noFill/>
+        </p:spPr>
+        <p:txBody>
+          <a:bodyPr wrap="square">
+            <a:spAutoFit/>
+          </a:bodyPr>
+          <a:lstStyle/>
+          <a:p>
+            <a:pPr algn="l">
+              <a:spcAft>
+                <a:spcPts val="800"/>
+              </a:spcAft>
+            </a:pPr>
+            <a:r>
+              <a:rPr sz="1500" b="1">
+                <a:solidFill>
+                  <a:srgbClr val="C9A24B"/>
+                </a:solidFill>
+                <a:latin typeface="Arial"/>
+              </a:rPr>
+              <a:t>La motivación detrás del proyecto</a:t>
+            </a:r>
+          </a:p>
+        </p:txBody>
+      </p:sp>
+      <p:sp>
+        <p:nvSpPr>
+          <p:cNvPr id="5" name="TextBox 4"/>
+          <p:cNvSpPr txBox="1"/>
+          <p:nvPr/>
+        </p:nvSpPr>
+        <p:spPr>
+          <a:xfrm>
+            <a:off x="822960" y="2148840"/>
+            <a:ext cx="10515600" cy="4206240"/>
+          </a:xfrm>
+          <a:prstGeom prst="rect">
+            <a:avLst/>
+          </a:prstGeom>
+          <a:noFill/>
+        </p:spPr>
+        <p:txBody>
+          <a:bodyPr wrap="square">
+            <a:spAutoFit/>
+          </a:bodyPr>
+          <a:lstStyle/>
+          <a:p>
+            <a:pPr algn="l">
+              <a:spcAft>
+                <a:spcPts val="1100"/>
+              </a:spcAft>
+            </a:pPr>
+            <a:r>
+              <a:rPr sz="1700" b="0">
+                <a:solidFill>
+                  <a:srgbClr val="444A55"/>
+                </a:solidFill>
+                <a:latin typeface="Arial"/>
+              </a:rPr>
+              <a:t>Los atributos generados por esta capa de NLP están pensados para integrarse, en el marco de la tesis de la maestría, como features de un modelo hedónico de valuación para detectar activos subvaluados en CABA.</a:t>
+            </a:r>
+          </a:p>
+          <a:p>
+            <a:pPr algn="l">
+              <a:spcAft>
+                <a:spcPts val="1100"/>
+              </a:spcAft>
+            </a:pPr>
+            <a:r>
+              <a:rPr sz="1700" b="0">
+                <a:solidFill>
+                  <a:srgbClr val="444A55"/>
+                </a:solidFill>
+                <a:latin typeface="Arial"/>
+              </a:rPr>
+              <a:t/>
+            </a:r>
+          </a:p>
+          <a:p>
+            <a:pPr algn="l">
+              <a:spcAft>
+                <a:spcPts val="1100"/>
+              </a:spcAft>
+            </a:pPr>
+            <a:r>
+              <a:rPr sz="1700" b="0">
+                <a:solidFill>
+                  <a:srgbClr val="444A55"/>
+                </a:solidFill>
+                <a:latin typeface="Arial"/>
+              </a:rPr>
+              <a:t>La hipótesis a testear: que las variables latentes extraídas del texto libre aporten poder explicativo por encima de los atributos tabulares tradicionales (metros, ambientes, ubicación, antigüedad).</a:t>
+            </a:r>
+          </a:p>
+          <a:p>
+            <a:pPr algn="l">
+              <a:spcAft>
+                <a:spcPts val="1100"/>
+              </a:spcAft>
+            </a:pPr>
+            <a:r>
+              <a:rPr sz="1700" b="0">
+                <a:solidFill>
+                  <a:srgbClr val="444A55"/>
+                </a:solidFill>
+                <a:latin typeface="Arial"/>
+              </a:rPr>
+              <a:t/>
+            </a:r>
+          </a:p>
+          <a:p>
+            <a:pPr algn="l">
+              <a:spcAft>
+                <a:spcPts val="1100"/>
+              </a:spcAft>
+            </a:pPr>
+            <a:r>
+              <a:rPr sz="1700" b="0">
+                <a:solidFill>
+                  <a:srgbClr val="444A55"/>
+                </a:solidFill>
+                <a:latin typeface="Arial"/>
+              </a:rPr>
+              <a:t>Esa integración excede el alcance del presente Trabajo Final y se menciona para dar cuenta de la continuidad del proyecto.</a:t>
+            </a:r>
+          </a:p>
+        </p:txBody>
+      </p:sp>
+    </p:spTree>
+  </p:cSld>
+  <p:clrMapOvr>
+    <a:masterClrMapping/>
+  </p:clrMapOvr>
+</p:sld>
+</file>
+
+<file path=ppt/slides/slide13.xml><?xml version="1.0" encoding="utf-8"?>
 <p:sld xmlns:a="http://schemas.openxmlformats.org/drawingml/2006/main" xmlns:p="http://schemas.openxmlformats.org/presentationml/2006/main" xmlns:r="http://schemas.openxmlformats.org/officeDocument/2006/relationships">
   <p:cSld>
     <p:bg>

</xml_diff>

<commit_message>
Gold humano de 45 avisos: NER real 0.202; la clasificacion no se puede evaluar (73% inmobiliarias, 2 positivos)
</commit_message>
<xml_diff>
--- a/entregables/TP_Final_Deep_Learning_Vassarotto.pptx
+++ b/entregables/TP_Final_Deep_Learning_Vassarotto.pptx
@@ -5932,7 +5932,7 @@
                 </a:solidFill>
                 <a:latin typeface="Arial"/>
               </a:rPr>
-              <a:t>19.7%</a:t>
+              <a:t>20.2%</a:t>
             </a:r>
           </a:p>
           <a:p>
@@ -5945,7 +5945,8 @@
                 <a:latin typeface="Arial"/>
               </a:rPr>
               <a:t>F1 NER
-sobre REAL</a:t>
+sobre REAL
+(gold humano)</a:t>
             </a:r>
           </a:p>
         </p:txBody>
@@ -6064,7 +6065,7 @@
                 </a:solidFill>
                 <a:latin typeface="Arial"/>
               </a:rPr>
-              <a:t>29.3%</a:t>
+              <a:t>45</a:t>
             </a:r>
           </a:p>
           <a:p>
@@ -6076,8 +6077,8 @@
                 </a:solidFill>
                 <a:latin typeface="Arial"/>
               </a:rPr>
-              <a:t>F1 macro clasif.
-sobre REAL</a:t>
+              <a:t>avisos revisados
+a mano</a:t>
             </a:r>
           </a:p>
         </p:txBody>
@@ -6116,7 +6117,7 @@
                 </a:solidFill>
                 <a:latin typeface="Arial"/>
               </a:rPr>
-              <a:t>Este contraste es el hallazgo central, y no se disimula: un F1 casi perfecto sobre datos sintéticos no mide qué tan bueno es el modelo, sino qué tan fácil es el test.</a:t>
+              <a:t>Un F1 casi perfecto sobre datos sintéticos no mide qué tan bueno es el modelo, sino qué tan fácil es el test: los avisos salen de plantillas y el modelo aprende la plantilla en lugar del concepto.</a:t>
             </a:r>
           </a:p>
           <a:p>
@@ -6148,7 +6149,7 @@
                 </a:solidFill>
                 <a:latin typeface="Arial"/>
               </a:rPr>
-              <a:t>Los avisos sintéticos salen de plantillas, así que el modelo aprende la plantilla en lugar del concepto.</a:t>
+              <a:t>El conjunto real es verdad de referencia HUMANA, no etiquetas de otro modelo. Contra el LLM el NER daba 0.197; contra el humano, 0.202: la conclusión no depende de quién anotó.</a:t>
             </a:r>
           </a:p>
         </p:txBody>
@@ -6213,7 +6214,7 @@
                 </a:solidFill>
                 <a:latin typeface="Arial"/>
               </a:rPr>
-              <a:t>Los dos modelos fallan distinto</a:t>
+              <a:t>Lo que sólo apareció al revisar a mano</a:t>
             </a:r>
           </a:p>
         </p:txBody>
@@ -6290,39 +6291,55 @@
               </a:spcAft>
             </a:pPr>
             <a:r>
-              <a:rPr sz="1500" b="0">
-                <a:solidFill>
-                  <a:srgbClr val="444A55"/>
-                </a:solidFill>
-                <a:latin typeface="Arial"/>
-              </a:rPr>
-              <a:t>EL NER SOBRE-ETIQUETA.</a:t>
-            </a:r>
-          </a:p>
-          <a:p>
-            <a:pPr algn="l">
-              <a:spcAft>
-                <a:spcPts val="1100"/>
-              </a:spcAft>
-            </a:pPr>
-            <a:r>
-              <a:rPr sz="1500" b="0">
-                <a:solidFill>
-                  <a:srgbClr val="444A55"/>
-                </a:solidFill>
-                <a:latin typeface="Arial"/>
-              </a:rPr>
-              <a:t>      Aprendió «sustantivo después de Cuenta con» en vez del vocabulario real de amenities. Sobre texto real marca AMENITY → «ventilación», «universidades», y llega a marcar el nombre de una calle como ORIENTACION.</a:t>
-            </a:r>
-          </a:p>
-          <a:p>
-            <a:pPr algn="l">
-              <a:spcAft>
-                <a:spcPts val="1100"/>
-              </a:spcAft>
-            </a:pPr>
-            <a:r>
-              <a:rPr sz="1500" b="0">
+              <a:rPr sz="1400" b="0">
+                <a:solidFill>
+                  <a:srgbClr val="444A55"/>
+                </a:solidFill>
+                <a:latin typeface="Arial"/>
+              </a:rPr>
+              <a:t>EL PRE-ANOTADOR LLM ALUCINABA.</a:t>
+            </a:r>
+          </a:p>
+          <a:p>
+            <a:pPr algn="l">
+              <a:spcAft>
+                <a:spcPts val="1100"/>
+              </a:spcAft>
+            </a:pPr>
+            <a:r>
+              <a:rPr sz="1400" b="0">
+                <a:solidFill>
+                  <a:srgbClr val="444A55"/>
+                </a:solidFill>
+                <a:latin typeface="Arial"/>
+              </a:rPr>
+              <a:t>      Propuso DUENO_DIRECTO en 21 avisos donde esa frase no aparece ni una vez. Y URGENCIA en 14, también sin ninguna mención real.</a:t>
+            </a:r>
+          </a:p>
+          <a:p>
+            <a:pPr algn="l">
+              <a:spcAft>
+                <a:spcPts val="1100"/>
+              </a:spcAft>
+            </a:pPr>
+            <a:r>
+              <a:rPr sz="1400" b="0">
+                <a:solidFill>
+                  <a:srgbClr val="444A55"/>
+                </a:solidFill>
+                <a:latin typeface="Arial"/>
+              </a:rPr>
+              <a:t>      Su falla dominante, sin embargo, es la OMISIÓN: el revisor agregó 84 entidades y borró 30. Encuentra menos de la mitad de lo que hay.</a:t>
+            </a:r>
+          </a:p>
+          <a:p>
+            <a:pPr algn="l">
+              <a:spcAft>
+                <a:spcPts val="1100"/>
+              </a:spcAft>
+            </a:pPr>
+            <a:r>
+              <a:rPr sz="1400" b="0">
                 <a:solidFill>
                   <a:srgbClr val="444A55"/>
                 </a:solidFill>
@@ -6338,39 +6355,55 @@
               </a:spcAft>
             </a:pPr>
             <a:r>
-              <a:rPr sz="1500" b="0">
-                <a:solidFill>
-                  <a:srgbClr val="444A55"/>
-                </a:solidFill>
-                <a:latin typeface="Arial"/>
-              </a:rPr>
-              <a:t>EL CLASIFICADOR CASI NO DISPARA.</a:t>
-            </a:r>
-          </a:p>
-          <a:p>
-            <a:pPr algn="l">
-              <a:spcAft>
-                <a:spcPts val="1100"/>
-              </a:spcAft>
-            </a:pPr>
-            <a:r>
-              <a:rPr sz="1500" b="0">
-                <a:solidFill>
-                  <a:srgbClr val="444A55"/>
-                </a:solidFill>
-                <a:latin typeface="Arial"/>
-              </a:rPr>
-              <a:t>      Precisión macro 0.55 pero recall 0.16: cuando predice suele acertar, pero se pierde la mayoría. Los avisos reales expresan «dueño directo» o «urgencia» con formas que el generador nunca produjo.</a:t>
-            </a:r>
-          </a:p>
-          <a:p>
-            <a:pPr algn="l">
-              <a:spcAft>
-                <a:spcPts val="1100"/>
-              </a:spcAft>
-            </a:pPr>
-            <a:r>
-              <a:rPr sz="1500" b="0">
+              <a:rPr sz="1400" b="0">
+                <a:solidFill>
+                  <a:srgbClr val="444A55"/>
+                </a:solidFill>
+                <a:latin typeface="Arial"/>
+              </a:rPr>
+              <a:t>LA CLASIFICACIÓN NO SE PUDO EVALUAR — y ese es el hallazgo.</a:t>
+            </a:r>
+          </a:p>
+          <a:p>
+            <a:pPr algn="l">
+              <a:spcAft>
+                <a:spcPts val="1100"/>
+              </a:spcAft>
+            </a:pPr>
+            <a:r>
+              <a:rPr sz="1400" b="0">
+                <a:solidFill>
+                  <a:srgbClr val="444A55"/>
+                </a:solidFill>
+                <a:latin typeface="Arial"/>
+              </a:rPr>
+              <a:t>      Tras la corrección quedaron 2 señales positivas en 45 avisos, con tres clases vacías. Cualquier F1 sería ruido, así que no se reporta ninguno.</a:t>
+            </a:r>
+          </a:p>
+          <a:p>
+            <a:pPr algn="l">
+              <a:spcAft>
+                <a:spcPts val="1100"/>
+              </a:spcAft>
+            </a:pPr>
+            <a:r>
+              <a:rPr sz="1400" b="0">
+                <a:solidFill>
+                  <a:srgbClr val="444A55"/>
+                </a:solidFill>
+                <a:latin typeface="Arial"/>
+              </a:rPr>
+              <a:t>      La causa: el 73% de la muestra son avisos de INMOBILIARIAS (llevan matrícula). Una inmobiliaria nunca escribe «dueño directo».</a:t>
+            </a:r>
+          </a:p>
+          <a:p>
+            <a:pPr algn="l">
+              <a:spcAft>
+                <a:spcPts val="1100"/>
+              </a:spcAft>
+            </a:pPr>
+            <a:r>
+              <a:rPr sz="1400" b="0">
                 <a:solidFill>
                   <a:srgbClr val="444A55"/>
                 </a:solidFill>
@@ -6386,29 +6419,29 @@
               </a:spcAft>
             </a:pPr>
             <a:r>
-              <a:rPr sz="1500" b="0">
-                <a:solidFill>
-                  <a:srgbClr val="444A55"/>
-                </a:solidFill>
-                <a:latin typeface="Arial"/>
-              </a:rPr>
-              <a:t>CÓMO LEER ESTOS NÚMEROS.</a:t>
-            </a:r>
-          </a:p>
-          <a:p>
-            <a:pPr algn="l">
-              <a:spcAft>
-                <a:spcPts val="1100"/>
-              </a:spcAft>
-            </a:pPr>
-            <a:r>
-              <a:rPr sz="1500" b="0">
-                <a:solidFill>
-                  <a:srgbClr val="444A55"/>
-                </a:solidFill>
-                <a:latin typeface="Arial"/>
-              </a:rPr>
-              <a:t>      Las etiquetas del conjunto real vienen del pre-anotador LLM sin revisión humana completa, sobre 65 avisos. Miden concordancia con un anotador imperfecto, no verdad de referencia. La magnitud de la caída es sólida; los valores exactos, no.</a:t>
+              <a:rPr sz="1400" b="0">
+                <a:solidFill>
+                  <a:srgbClr val="444A55"/>
+                </a:solidFill>
+                <a:latin typeface="Arial"/>
+              </a:rPr>
+              <a:t>CONSECUENCIA METODOLÓGICA.</a:t>
+            </a:r>
+          </a:p>
+          <a:p>
+            <a:pPr algn="l">
+              <a:spcAft>
+                <a:spcPts val="1100"/>
+              </a:spcAft>
+            </a:pPr>
+            <a:r>
+              <a:rPr sz="1400" b="0">
+                <a:solidFill>
+                  <a:srgbClr val="444A55"/>
+                </a:solidFill>
+                <a:latin typeface="Arial"/>
+              </a:rPr>
+              <a:t>      Para evaluar esa capa hace falta muestrear avisos de particulares. No es una falla del modelo sino del conjunto con el que se lo probó.</a:t>
             </a:r>
           </a:p>
         </p:txBody>

</xml_diff>